<commit_message>
docs(release): 追平十八批审计与最终用例数（14,976 / 7,420 / 22,396）
- 候选冻结点 d841ec0a；README/CHANGELOG/发布说明统一十八批口径。
- 后端 14,976、前端 7,420、总 22,396；三份 PPT 同步，页数保持 56/44/60。
- 发布说明明确本地 34bf 安装包仅验证构建链，最终产物以 v1.18.26 tag CI 为准；
  NSIS 安装限制继续如实标注。
</commit_message>
<xml_diff>
--- a/docs/帮扶管理信息系统介绍-零基础版.pptx
+++ b/docs/帮扶管理信息系统介绍-零基础版.pptx
@@ -27939,7 +27939,7 @@
                   <a:ea typeface="+mn-ea"/>
                   <a:cs typeface="+mn-cs"/>
                 </a:rPr>
-                <a:t>22,373</a:t>
+                <a:t>22,396</a:t>
               </a:r>
             </a:p>
           </p:txBody>
@@ -28319,7 +28319,7 @@
                   <a:ea typeface="+mn-ea"/>
                   <a:cs typeface="+mn-cs"/>
                 </a:rPr>
-                <a:t>数据来源：2026-10-29 实测（v1.18.26）—— 后端 14,953 用例 + 前端 7,420 用例</a:t>
+                <a:t>数据来源：2026-10-29 实测（v1.18.26）—— 后端 14,976 用例 + 前端 7,420 用例</a:t>
               </a:r>
             </a:p>
           </p:txBody>
@@ -29152,7 +29152,7 @@
                   <a:ea typeface="+mn-ea"/>
                   <a:cs typeface="+mn-cs"/>
                 </a:rPr>
-                <a:t>后端 14,953 个自动化用例，前端 7,420 个用例，每次改动全部重跑。</a:t>
+                <a:t>后端 14,976 个自动化用例，前端 7,420 个用例，每次改动全部重跑。</a:t>
               </a:r>
             </a:p>
           </p:txBody>
@@ -43151,7 +43151,7 @@
                 <a:ea typeface="+mn-ea"/>
                 <a:cs typeface="+mn-cs"/>
               </a:rPr>
-              <a:t>22,373 项自动化测试守护 · 双平台离线交付 · 数据不出本机</a:t>
+              <a:t>22,396 项自动化测试守护 · 双平台离线交付 · 数据不出本机</a:t>
             </a:r>
           </a:p>
         </p:txBody>

</xml_diff>

<commit_message>
docs(release): 追平 35 道门禁与 14,994/7,428 最终口径
- 版本 1.18.26；后端 14,994 / 前端 348 文件 7,428 / 总 22,422。
- 三份 PPT 同步；页数 56/44/60，旧 token 0。
- 发布说明冻结点 be8dee31（44 提交，审计 1~18 批）。
</commit_message>
<xml_diff>
--- a/docs/帮扶管理信息系统介绍-零基础版.pptx
+++ b/docs/帮扶管理信息系统介绍-零基础版.pptx
@@ -27939,7 +27939,7 @@
                   <a:ea typeface="+mn-ea"/>
                   <a:cs typeface="+mn-cs"/>
                 </a:rPr>
-                <a:t>22,396</a:t>
+                <a:t>22,422</a:t>
               </a:r>
             </a:p>
           </p:txBody>
@@ -28319,7 +28319,7 @@
                   <a:ea typeface="+mn-ea"/>
                   <a:cs typeface="+mn-cs"/>
                 </a:rPr>
-                <a:t>数据来源：2026-10-29 实测（v1.18.26）—— 后端 14,976 用例 + 前端 7,420 用例</a:t>
+                <a:t>数据来源：2026-10-29 实测（v1.18.26）—— 后端 14,994 用例 + 前端 7,428 用例</a:t>
               </a:r>
             </a:p>
           </p:txBody>
@@ -29152,7 +29152,7 @@
                   <a:ea typeface="+mn-ea"/>
                   <a:cs typeface="+mn-cs"/>
                 </a:rPr>
-                <a:t>后端 14,976 个自动化用例，前端 7,420 个用例，每次改动全部重跑。</a:t>
+                <a:t>后端 14,994 个自动化用例，前端 7,428 个用例，每次改动全部重跑。</a:t>
               </a:r>
             </a:p>
           </p:txBody>
@@ -43151,7 +43151,7 @@
                 <a:ea typeface="+mn-ea"/>
                 <a:cs typeface="+mn-cs"/>
               </a:rPr>
-              <a:t>22,396 项自动化测试守护 · 双平台离线交付 · 数据不出本机</a:t>
+              <a:t>22,422 项自动化测试守护 · 双平台离线交付 · 数据不出本机</a:t>
             </a:r>
           </a:p>
         </p:txBody>

</xml_diff>